<commit_message>
Publish Week 3 partial guide
</commit_message>
<xml_diff>
--- a/assets/slides/lecture-04-slides.pptx
+++ b/assets/slides/lecture-04-slides.pptx
@@ -1496,7 +1496,7 @@
           <a:p>
             <a:fld id="{5BCAD085-E8A6-8845-BD4E-CB4CCA059FC4}" type="datetimeFigureOut">
               <a:rPr lang="en-US" smtClean="0"/>
-              <a:t>9/11/2026</a:t>
+              <a:t>9/14/2026</a:t>
             </a:fld>
             <a:endParaRPr lang="en-US"/>
           </a:p>
@@ -1664,7 +1664,7 @@
           <a:p>
             <a:fld id="{5BCAD085-E8A6-8845-BD4E-CB4CCA059FC4}" type="datetimeFigureOut">
               <a:rPr lang="en-US" smtClean="0"/>
-              <a:t>9/11/2026</a:t>
+              <a:t>9/14/2026</a:t>
             </a:fld>
             <a:endParaRPr lang="en-US"/>
           </a:p>
@@ -1842,7 +1842,7 @@
           <a:p>
             <a:fld id="{5BCAD085-E8A6-8845-BD4E-CB4CCA059FC4}" type="datetimeFigureOut">
               <a:rPr lang="en-US" smtClean="0"/>
-              <a:t>9/11/2026</a:t>
+              <a:t>9/14/2026</a:t>
             </a:fld>
             <a:endParaRPr lang="en-US"/>
           </a:p>
@@ -2010,7 +2010,7 @@
           <a:p>
             <a:fld id="{5BCAD085-E8A6-8845-BD4E-CB4CCA059FC4}" type="datetimeFigureOut">
               <a:rPr lang="en-US" smtClean="0"/>
-              <a:t>9/11/2026</a:t>
+              <a:t>9/14/2026</a:t>
             </a:fld>
             <a:endParaRPr lang="en-US"/>
           </a:p>
@@ -2255,7 +2255,7 @@
           <a:p>
             <a:fld id="{5BCAD085-E8A6-8845-BD4E-CB4CCA059FC4}" type="datetimeFigureOut">
               <a:rPr lang="en-US" smtClean="0"/>
-              <a:t>9/11/2026</a:t>
+              <a:t>9/14/2026</a:t>
             </a:fld>
             <a:endParaRPr lang="en-US"/>
           </a:p>
@@ -2540,7 +2540,7 @@
           <a:p>
             <a:fld id="{5BCAD085-E8A6-8845-BD4E-CB4CCA059FC4}" type="datetimeFigureOut">
               <a:rPr lang="en-US" smtClean="0"/>
-              <a:t>9/11/2026</a:t>
+              <a:t>9/14/2026</a:t>
             </a:fld>
             <a:endParaRPr lang="en-US"/>
           </a:p>
@@ -2959,7 +2959,7 @@
           <a:p>
             <a:fld id="{5BCAD085-E8A6-8845-BD4E-CB4CCA059FC4}" type="datetimeFigureOut">
               <a:rPr lang="en-US" smtClean="0"/>
-              <a:t>9/11/2026</a:t>
+              <a:t>9/14/2026</a:t>
             </a:fld>
             <a:endParaRPr lang="en-US"/>
           </a:p>
@@ -3076,7 +3076,7 @@
           <a:p>
             <a:fld id="{5BCAD085-E8A6-8845-BD4E-CB4CCA059FC4}" type="datetimeFigureOut">
               <a:rPr lang="en-US" smtClean="0"/>
-              <a:t>9/11/2026</a:t>
+              <a:t>9/14/2026</a:t>
             </a:fld>
             <a:endParaRPr lang="en-US"/>
           </a:p>
@@ -3171,7 +3171,7 @@
           <a:p>
             <a:fld id="{5BCAD085-E8A6-8845-BD4E-CB4CCA059FC4}" type="datetimeFigureOut">
               <a:rPr lang="en-US" smtClean="0"/>
-              <a:t>9/11/2026</a:t>
+              <a:t>9/14/2026</a:t>
             </a:fld>
             <a:endParaRPr lang="en-US"/>
           </a:p>
@@ -3446,7 +3446,7 @@
           <a:p>
             <a:fld id="{5BCAD085-E8A6-8845-BD4E-CB4CCA059FC4}" type="datetimeFigureOut">
               <a:rPr lang="en-US" smtClean="0"/>
-              <a:t>9/11/2026</a:t>
+              <a:t>9/14/2026</a:t>
             </a:fld>
             <a:endParaRPr lang="en-US"/>
           </a:p>
@@ -3698,7 +3698,7 @@
           <a:p>
             <a:fld id="{5BCAD085-E8A6-8845-BD4E-CB4CCA059FC4}" type="datetimeFigureOut">
               <a:rPr lang="en-US" smtClean="0"/>
-              <a:t>9/11/2026</a:t>
+              <a:t>9/14/2026</a:t>
             </a:fld>
             <a:endParaRPr lang="en-US"/>
           </a:p>
@@ -3909,7 +3909,7 @@
           <a:p>
             <a:fld id="{5BCAD085-E8A6-8845-BD4E-CB4CCA059FC4}" type="datetimeFigureOut">
               <a:rPr lang="en-US" smtClean="0"/>
-              <a:t>9/11/2026</a:t>
+              <a:t>9/14/2026</a:t>
             </a:fld>
             <a:endParaRPr lang="en-US"/>
           </a:p>

</xml_diff>